<commit_message>
Added a reference paper
</commit_message>
<xml_diff>
--- a/Corporate-Bankruptcy-Prediction-Using-Machine-Learning (1).pptx
+++ b/Corporate-Bankruptcy-Prediction-Using-Machine-Learning (1).pptx
@@ -13,9 +13,8 @@
     <p:sldId id="261" r:id="rId7"/>
     <p:sldId id="262" r:id="rId8"/>
     <p:sldId id="263" r:id="rId9"/>
-    <p:sldId id="266" r:id="rId10"/>
-    <p:sldId id="264" r:id="rId11"/>
-    <p:sldId id="265" r:id="rId12"/>
+    <p:sldId id="264" r:id="rId10"/>
+    <p:sldId id="265" r:id="rId11"/>
   </p:sldIdLst>
   <p:sldSz cx="12192000" cy="6858000"/>
   <p:notesSz cx="12192000" cy="6858000"/>
@@ -192,7 +191,7 @@
           <a:p>
             <a:fld id="{1D8BD707-D9CF-40AE-B4C6-C98DA3205C09}" type="datetimeFigureOut">
               <a:rPr lang="en-US"/>
-              <a:t>10/15/2026</a:t>
+              <a:t>10/3/2026</a:t>
             </a:fld>
             <a:endParaRPr lang="en-US"/>
           </a:p>
@@ -367,7 +366,7 @@
           <a:p>
             <a:fld id="{1D8BD707-D9CF-40AE-B4C6-C98DA3205C09}" type="datetimeFigureOut">
               <a:rPr lang="en-US"/>
-              <a:t>10/15/2026</a:t>
+              <a:t>10/3/2026</a:t>
             </a:fld>
             <a:endParaRPr lang="en-US"/>
           </a:p>
@@ -581,7 +580,7 @@
           <a:p>
             <a:fld id="{1D8BD707-D9CF-40AE-B4C6-C98DA3205C09}" type="datetimeFigureOut">
               <a:rPr lang="en-US"/>
-              <a:t>10/15/2026</a:t>
+              <a:t>10/3/2026</a:t>
             </a:fld>
             <a:endParaRPr lang="en-US"/>
           </a:p>
@@ -729,7 +728,7 @@
           <a:p>
             <a:fld id="{1D8BD707-D9CF-40AE-B4C6-C98DA3205C09}" type="datetimeFigureOut">
               <a:rPr lang="en-US"/>
-              <a:t>10/15/2026</a:t>
+              <a:t>10/3/2026</a:t>
             </a:fld>
             <a:endParaRPr lang="en-US"/>
           </a:p>
@@ -848,7 +847,7 @@
           <a:p>
             <a:fld id="{1D8BD707-D9CF-40AE-B4C6-C98DA3205C09}" type="datetimeFigureOut">
               <a:rPr lang="en-US"/>
-              <a:t>10/15/2026</a:t>
+              <a:t>10/3/2026</a:t>
             </a:fld>
             <a:endParaRPr lang="en-US"/>
           </a:p>
@@ -1121,7 +1120,7 @@
           <a:p>
             <a:fld id="{1D8BD707-D9CF-40AE-B4C6-C98DA3205C09}" type="datetimeFigureOut">
               <a:rPr lang="en-US"/>
-              <a:t>10/15/2026</a:t>
+              <a:t>10/3/2026</a:t>
             </a:fld>
             <a:endParaRPr lang="en-US"/>
           </a:p>
@@ -1836,1034 +1835,6 @@
 </file>
 
 <file path=ppt/slides/slide10.xml><?xml version="1.0" encoding="utf-8"?>
-<p:sld xmlns:a="http://schemas.openxmlformats.org/drawingml/2006/main" xmlns:r="http://schemas.openxmlformats.org/officeDocument/2006/relationships" xmlns:p="http://schemas.openxmlformats.org/presentationml/2006/main">
-  <p:cSld>
-    <p:spTree>
-      <p:nvGrpSpPr>
-        <p:cNvPr id="1" name=""/>
-        <p:cNvGrpSpPr/>
-        <p:nvPr/>
-      </p:nvGrpSpPr>
-      <p:grpSpPr>
-        <a:xfrm>
-          <a:off x="0" y="0"/>
-          <a:ext cx="0" cy="0"/>
-          <a:chOff x="0" y="0"/>
-          <a:chExt cx="0" cy="0"/>
-        </a:xfrm>
-      </p:grpSpPr>
-      <p:sp>
-        <p:nvSpPr>
-          <p:cNvPr id="2" name="object 2"/>
-          <p:cNvSpPr txBox="1"/>
-          <p:nvPr/>
-        </p:nvSpPr>
-        <p:spPr>
-          <a:xfrm>
-            <a:off x="596899" y="596900"/>
-            <a:ext cx="772795" cy="208279"/>
-          </a:xfrm>
-          <a:prstGeom prst="rect">
-            <a:avLst/>
-          </a:prstGeom>
-        </p:spPr>
-        <p:txBody>
-          <a:bodyPr vert="horz" wrap="square" lIns="0" tIns="12700" rIns="0" bIns="0" rtlCol="0">
-            <a:spAutoFit/>
-          </a:bodyPr>
-          <a:lstStyle/>
-          <a:p>
-            <a:pPr marL="12700">
-              <a:lnSpc>
-                <a:spcPct val="100000"/>
-              </a:lnSpc>
-              <a:spcBef>
-                <a:spcPts val="100"/>
-              </a:spcBef>
-            </a:pPr>
-            <a:r>
-              <a:rPr sz="1200" b="1" spc="45" dirty="0">
-                <a:solidFill>
-                  <a:srgbClr val="3D5C73"/>
-                </a:solidFill>
-                <a:latin typeface="Tahoma"/>
-                <a:cs typeface="Tahoma"/>
-              </a:rPr>
-              <a:t>RESULTS</a:t>
-            </a:r>
-            <a:endParaRPr sz="1200">
-              <a:latin typeface="Tahoma"/>
-              <a:cs typeface="Tahoma"/>
-            </a:endParaRPr>
-          </a:p>
-        </p:txBody>
-      </p:sp>
-      <p:sp>
-        <p:nvSpPr>
-          <p:cNvPr id="3" name="object 3" descr="$PPTXTitle"/>
-          <p:cNvSpPr txBox="1">
-            <a:spLocks noGrp="1"/>
-          </p:cNvSpPr>
-          <p:nvPr>
-            <p:ph type="title"/>
-          </p:nvPr>
-        </p:nvSpPr>
-        <p:spPr>
-          <a:xfrm>
-            <a:off x="596899" y="863600"/>
-            <a:ext cx="9313545" cy="482600"/>
-          </a:xfrm>
-          <a:prstGeom prst="rect">
-            <a:avLst/>
-          </a:prstGeom>
-        </p:spPr>
-        <p:txBody>
-          <a:bodyPr vert="horz" wrap="square" lIns="0" tIns="12700" rIns="0" bIns="0" rtlCol="0">
-            <a:spAutoFit/>
-          </a:bodyPr>
-          <a:lstStyle/>
-          <a:p>
-            <a:pPr marL="12700">
-              <a:lnSpc>
-                <a:spcPct val="100000"/>
-              </a:lnSpc>
-              <a:spcBef>
-                <a:spcPts val="100"/>
-              </a:spcBef>
-            </a:pPr>
-            <a:r>
-              <a:rPr spc="-130" dirty="0"/>
-              <a:t>Random</a:t>
-            </a:r>
-            <a:r>
-              <a:rPr spc="-114" dirty="0"/>
-              <a:t> </a:t>
-            </a:r>
-            <a:r>
-              <a:rPr spc="-90" dirty="0"/>
-              <a:t>Forest</a:t>
-            </a:r>
-            <a:r>
-              <a:rPr spc="-114" dirty="0"/>
-              <a:t> </a:t>
-            </a:r>
-            <a:r>
-              <a:rPr spc="-75" dirty="0"/>
-              <a:t>was</a:t>
-            </a:r>
-            <a:r>
-              <a:rPr spc="-114" dirty="0"/>
-              <a:t> </a:t>
-            </a:r>
-            <a:r>
-              <a:rPr spc="-120" dirty="0"/>
-              <a:t>the</a:t>
-            </a:r>
-            <a:r>
-              <a:rPr spc="-114" dirty="0"/>
-              <a:t> </a:t>
-            </a:r>
-            <a:r>
-              <a:rPr spc="-85" dirty="0"/>
-              <a:t>strongest</a:t>
-            </a:r>
-            <a:r>
-              <a:rPr spc="-114" dirty="0"/>
-              <a:t> </a:t>
-            </a:r>
-            <a:r>
-              <a:rPr spc="-110" dirty="0"/>
-              <a:t>overall</a:t>
-            </a:r>
-            <a:r>
-              <a:rPr spc="-114" dirty="0"/>
-              <a:t> </a:t>
-            </a:r>
-            <a:r>
-              <a:rPr spc="-40" dirty="0"/>
-              <a:t>extension</a:t>
-            </a:r>
-          </a:p>
-        </p:txBody>
-      </p:sp>
-      <p:sp>
-        <p:nvSpPr>
-          <p:cNvPr id="4" name="object 4"/>
-          <p:cNvSpPr/>
-          <p:nvPr/>
-        </p:nvSpPr>
-        <p:spPr>
-          <a:xfrm>
-            <a:off x="609599" y="1714499"/>
-            <a:ext cx="10972800" cy="9525"/>
-          </a:xfrm>
-          <a:custGeom>
-            <a:avLst/>
-            <a:gdLst/>
-            <a:ahLst/>
-            <a:cxnLst/>
-            <a:rect l="l" t="t" r="r" b="b"/>
-            <a:pathLst>
-              <a:path w="10972800" h="9525">
-                <a:moveTo>
-                  <a:pt x="10969351" y="9524"/>
-                </a:moveTo>
-                <a:lnTo>
-                  <a:pt x="3447" y="9524"/>
-                </a:lnTo>
-                <a:lnTo>
-                  <a:pt x="2324" y="9059"/>
-                </a:lnTo>
-                <a:lnTo>
-                  <a:pt x="464" y="7200"/>
-                </a:lnTo>
-                <a:lnTo>
-                  <a:pt x="0" y="6077"/>
-                </a:lnTo>
-                <a:lnTo>
-                  <a:pt x="0" y="4762"/>
-                </a:lnTo>
-                <a:lnTo>
-                  <a:pt x="0" y="3447"/>
-                </a:lnTo>
-                <a:lnTo>
-                  <a:pt x="464" y="2324"/>
-                </a:lnTo>
-                <a:lnTo>
-                  <a:pt x="2324" y="464"/>
-                </a:lnTo>
-                <a:lnTo>
-                  <a:pt x="3447" y="0"/>
-                </a:lnTo>
-                <a:lnTo>
-                  <a:pt x="10969351" y="0"/>
-                </a:lnTo>
-                <a:lnTo>
-                  <a:pt x="10970473" y="464"/>
-                </a:lnTo>
-                <a:lnTo>
-                  <a:pt x="10972332" y="2324"/>
-                </a:lnTo>
-                <a:lnTo>
-                  <a:pt x="10972798" y="3447"/>
-                </a:lnTo>
-                <a:lnTo>
-                  <a:pt x="10972798" y="6077"/>
-                </a:lnTo>
-                <a:lnTo>
-                  <a:pt x="10972332" y="7200"/>
-                </a:lnTo>
-                <a:lnTo>
-                  <a:pt x="10970473" y="9059"/>
-                </a:lnTo>
-                <a:lnTo>
-                  <a:pt x="10969351" y="9524"/>
-                </a:lnTo>
-                <a:close/>
-              </a:path>
-            </a:pathLst>
-          </a:custGeom>
-          <a:solidFill>
-            <a:srgbClr val="17324A"/>
-          </a:solidFill>
-        </p:spPr>
-        <p:txBody>
-          <a:bodyPr wrap="square" lIns="0" tIns="0" rIns="0" bIns="0" rtlCol="0"/>
-          <a:lstStyle/>
-          <a:p>
-            <a:endParaRPr/>
-          </a:p>
-        </p:txBody>
-      </p:sp>
-      <p:sp>
-        <p:nvSpPr>
-          <p:cNvPr id="5" name="object 5"/>
-          <p:cNvSpPr txBox="1"/>
-          <p:nvPr/>
-        </p:nvSpPr>
-        <p:spPr>
-          <a:xfrm>
-            <a:off x="596899" y="2009762"/>
-            <a:ext cx="6839584" cy="1206500"/>
-          </a:xfrm>
-          <a:prstGeom prst="rect">
-            <a:avLst/>
-          </a:prstGeom>
-        </p:spPr>
-        <p:txBody>
-          <a:bodyPr vert="horz" wrap="square" lIns="0" tIns="7620" rIns="0" bIns="0" rtlCol="0">
-            <a:spAutoFit/>
-          </a:bodyPr>
-          <a:lstStyle/>
-          <a:p>
-            <a:pPr marL="12700" marR="5080" algn="just">
-              <a:lnSpc>
-                <a:spcPct val="129700"/>
-              </a:lnSpc>
-              <a:spcBef>
-                <a:spcPts val="60"/>
-              </a:spcBef>
-            </a:pPr>
-            <a:r>
-              <a:rPr sz="2000" spc="70" dirty="0">
-                <a:solidFill>
-                  <a:srgbClr val="4E5862"/>
-                </a:solidFill>
-                <a:latin typeface="Tahoma"/>
-                <a:cs typeface="Tahoma"/>
-              </a:rPr>
-              <a:t>Multiple</a:t>
-            </a:r>
-            <a:r>
-              <a:rPr sz="2000" spc="-50" dirty="0">
-                <a:solidFill>
-                  <a:srgbClr val="4E5862"/>
-                </a:solidFill>
-                <a:latin typeface="Tahoma"/>
-                <a:cs typeface="Tahoma"/>
-              </a:rPr>
-              <a:t> </a:t>
-            </a:r>
-            <a:r>
-              <a:rPr sz="2000" spc="95" dirty="0">
-                <a:solidFill>
-                  <a:srgbClr val="4E5862"/>
-                </a:solidFill>
-                <a:latin typeface="Tahoma"/>
-                <a:cs typeface="Tahoma"/>
-              </a:rPr>
-              <a:t>decision</a:t>
-            </a:r>
-            <a:r>
-              <a:rPr sz="2000" spc="-45" dirty="0">
-                <a:solidFill>
-                  <a:srgbClr val="4E5862"/>
-                </a:solidFill>
-                <a:latin typeface="Tahoma"/>
-                <a:cs typeface="Tahoma"/>
-              </a:rPr>
-              <a:t> </a:t>
-            </a:r>
-            <a:r>
-              <a:rPr sz="2000" spc="65" dirty="0">
-                <a:solidFill>
-                  <a:srgbClr val="4E5862"/>
-                </a:solidFill>
-                <a:latin typeface="Tahoma"/>
-                <a:cs typeface="Tahoma"/>
-              </a:rPr>
-              <a:t>trees</a:t>
-            </a:r>
-            <a:r>
-              <a:rPr sz="2000" spc="-45" dirty="0">
-                <a:solidFill>
-                  <a:srgbClr val="4E5862"/>
-                </a:solidFill>
-                <a:latin typeface="Tahoma"/>
-                <a:cs typeface="Tahoma"/>
-              </a:rPr>
-              <a:t> </a:t>
-            </a:r>
-            <a:r>
-              <a:rPr sz="2000" spc="114" dirty="0">
-                <a:solidFill>
-                  <a:srgbClr val="4E5862"/>
-                </a:solidFill>
-                <a:latin typeface="Tahoma"/>
-                <a:cs typeface="Tahoma"/>
-              </a:rPr>
-              <a:t>can</a:t>
-            </a:r>
-            <a:r>
-              <a:rPr sz="2000" spc="-45" dirty="0">
-                <a:solidFill>
-                  <a:srgbClr val="4E5862"/>
-                </a:solidFill>
-                <a:latin typeface="Tahoma"/>
-                <a:cs typeface="Tahoma"/>
-              </a:rPr>
-              <a:t> </a:t>
-            </a:r>
-            <a:r>
-              <a:rPr sz="2000" spc="80" dirty="0">
-                <a:solidFill>
-                  <a:srgbClr val="4E5862"/>
-                </a:solidFill>
-                <a:latin typeface="Tahoma"/>
-                <a:cs typeface="Tahoma"/>
-              </a:rPr>
-              <a:t>model</a:t>
-            </a:r>
-            <a:r>
-              <a:rPr sz="2000" spc="-45" dirty="0">
-                <a:solidFill>
-                  <a:srgbClr val="4E5862"/>
-                </a:solidFill>
-                <a:latin typeface="Tahoma"/>
-                <a:cs typeface="Tahoma"/>
-              </a:rPr>
-              <a:t> </a:t>
-            </a:r>
-            <a:r>
-              <a:rPr sz="2000" spc="55" dirty="0">
-                <a:solidFill>
-                  <a:srgbClr val="4E5862"/>
-                </a:solidFill>
-                <a:latin typeface="Tahoma"/>
-                <a:cs typeface="Tahoma"/>
-              </a:rPr>
-              <a:t>nonlinear</a:t>
-            </a:r>
-            <a:r>
-              <a:rPr sz="2000" spc="-50" dirty="0">
-                <a:solidFill>
-                  <a:srgbClr val="4E5862"/>
-                </a:solidFill>
-                <a:latin typeface="Tahoma"/>
-                <a:cs typeface="Tahoma"/>
-              </a:rPr>
-              <a:t> </a:t>
-            </a:r>
-            <a:r>
-              <a:rPr sz="2000" spc="50" dirty="0">
-                <a:solidFill>
-                  <a:srgbClr val="4E5862"/>
-                </a:solidFill>
-                <a:latin typeface="Tahoma"/>
-                <a:cs typeface="Tahoma"/>
-              </a:rPr>
-              <a:t>relationships </a:t>
-            </a:r>
-            <a:r>
-              <a:rPr sz="2000" spc="65" dirty="0">
-                <a:solidFill>
-                  <a:srgbClr val="4E5862"/>
-                </a:solidFill>
-                <a:latin typeface="Tahoma"/>
-                <a:cs typeface="Tahoma"/>
-              </a:rPr>
-              <a:t>while</a:t>
-            </a:r>
-            <a:r>
-              <a:rPr sz="2000" spc="-35" dirty="0">
-                <a:solidFill>
-                  <a:srgbClr val="4E5862"/>
-                </a:solidFill>
-                <a:latin typeface="Tahoma"/>
-                <a:cs typeface="Tahoma"/>
-              </a:rPr>
-              <a:t> </a:t>
-            </a:r>
-            <a:r>
-              <a:rPr sz="2000" spc="50" dirty="0">
-                <a:solidFill>
-                  <a:srgbClr val="4E5862"/>
-                </a:solidFill>
-                <a:latin typeface="Tahoma"/>
-                <a:cs typeface="Tahoma"/>
-              </a:rPr>
-              <a:t>remaining</a:t>
-            </a:r>
-            <a:r>
-              <a:rPr sz="2000" spc="-30" dirty="0">
-                <a:solidFill>
-                  <a:srgbClr val="4E5862"/>
-                </a:solidFill>
-                <a:latin typeface="Tahoma"/>
-                <a:cs typeface="Tahoma"/>
-              </a:rPr>
-              <a:t> </a:t>
-            </a:r>
-            <a:r>
-              <a:rPr sz="2000" spc="65" dirty="0">
-                <a:solidFill>
-                  <a:srgbClr val="4E5862"/>
-                </a:solidFill>
-                <a:latin typeface="Tahoma"/>
-                <a:cs typeface="Tahoma"/>
-              </a:rPr>
-              <a:t>robust</a:t>
-            </a:r>
-            <a:r>
-              <a:rPr sz="2000" spc="-30" dirty="0">
-                <a:solidFill>
-                  <a:srgbClr val="4E5862"/>
-                </a:solidFill>
-                <a:latin typeface="Tahoma"/>
-                <a:cs typeface="Tahoma"/>
-              </a:rPr>
-              <a:t> </a:t>
-            </a:r>
-            <a:r>
-              <a:rPr sz="2000" spc="110" dirty="0">
-                <a:solidFill>
-                  <a:srgbClr val="4E5862"/>
-                </a:solidFill>
-                <a:latin typeface="Tahoma"/>
-                <a:cs typeface="Tahoma"/>
-              </a:rPr>
-              <a:t>across</a:t>
-            </a:r>
-            <a:r>
-              <a:rPr sz="2000" spc="-30" dirty="0">
-                <a:solidFill>
-                  <a:srgbClr val="4E5862"/>
-                </a:solidFill>
-                <a:latin typeface="Tahoma"/>
-                <a:cs typeface="Tahoma"/>
-              </a:rPr>
-              <a:t> </a:t>
-            </a:r>
-            <a:r>
-              <a:rPr sz="2000" dirty="0">
-                <a:solidFill>
-                  <a:srgbClr val="4E5862"/>
-                </a:solidFill>
-                <a:latin typeface="Tahoma"/>
-                <a:cs typeface="Tahoma"/>
-              </a:rPr>
-              <a:t>the</a:t>
-            </a:r>
-            <a:r>
-              <a:rPr sz="2000" spc="-30" dirty="0">
-                <a:solidFill>
-                  <a:srgbClr val="4E5862"/>
-                </a:solidFill>
-                <a:latin typeface="Tahoma"/>
-                <a:cs typeface="Tahoma"/>
-              </a:rPr>
-              <a:t> </a:t>
-            </a:r>
-            <a:r>
-              <a:rPr sz="2000" spc="95" dirty="0">
-                <a:solidFill>
-                  <a:srgbClr val="4E5862"/>
-                </a:solidFill>
-                <a:latin typeface="Tahoma"/>
-                <a:cs typeface="Tahoma"/>
-              </a:rPr>
-              <a:t>same</a:t>
-            </a:r>
-            <a:r>
-              <a:rPr sz="2000" spc="-35" dirty="0">
-                <a:solidFill>
-                  <a:srgbClr val="4E5862"/>
-                </a:solidFill>
-                <a:latin typeface="Tahoma"/>
-                <a:cs typeface="Tahoma"/>
-              </a:rPr>
-              <a:t> </a:t>
-            </a:r>
-            <a:r>
-              <a:rPr sz="2000" spc="65" dirty="0">
-                <a:solidFill>
-                  <a:srgbClr val="4E5862"/>
-                </a:solidFill>
-                <a:latin typeface="Tahoma"/>
-                <a:cs typeface="Tahoma"/>
-              </a:rPr>
-              <a:t>financial</a:t>
-            </a:r>
-            <a:r>
-              <a:rPr sz="2000" spc="-30" dirty="0">
-                <a:solidFill>
-                  <a:srgbClr val="4E5862"/>
-                </a:solidFill>
-                <a:latin typeface="Tahoma"/>
-                <a:cs typeface="Tahoma"/>
-              </a:rPr>
-              <a:t> </a:t>
-            </a:r>
-            <a:r>
-              <a:rPr sz="2000" spc="40" dirty="0">
-                <a:solidFill>
-                  <a:srgbClr val="4E5862"/>
-                </a:solidFill>
-                <a:latin typeface="Tahoma"/>
-                <a:cs typeface="Tahoma"/>
-              </a:rPr>
-              <a:t>feature </a:t>
-            </a:r>
-            <a:r>
-              <a:rPr sz="2000" spc="95" dirty="0">
-                <a:solidFill>
-                  <a:srgbClr val="4E5862"/>
-                </a:solidFill>
-                <a:latin typeface="Tahoma"/>
-                <a:cs typeface="Tahoma"/>
-              </a:rPr>
-              <a:t>space.</a:t>
-            </a:r>
-            <a:endParaRPr sz="2000">
-              <a:latin typeface="Tahoma"/>
-              <a:cs typeface="Tahoma"/>
-            </a:endParaRPr>
-          </a:p>
-        </p:txBody>
-      </p:sp>
-      <p:sp>
-        <p:nvSpPr>
-          <p:cNvPr id="6" name="object 6"/>
-          <p:cNvSpPr txBox="1"/>
-          <p:nvPr/>
-        </p:nvSpPr>
-        <p:spPr>
-          <a:xfrm>
-            <a:off x="614362" y="4557712"/>
-            <a:ext cx="3448050" cy="1685925"/>
-          </a:xfrm>
-          <a:prstGeom prst="rect">
-            <a:avLst/>
-          </a:prstGeom>
-          <a:ln w="9524">
-            <a:solidFill>
-              <a:srgbClr val="D8D5CD"/>
-            </a:solidFill>
-          </a:ln>
-        </p:spPr>
-        <p:txBody>
-          <a:bodyPr vert="horz" wrap="square" lIns="0" tIns="0" rIns="0" bIns="0" rtlCol="0">
-            <a:spAutoFit/>
-          </a:bodyPr>
-          <a:lstStyle/>
-          <a:p>
-            <a:pPr>
-              <a:lnSpc>
-                <a:spcPct val="100000"/>
-              </a:lnSpc>
-            </a:pPr>
-            <a:endParaRPr sz="1200">
-              <a:latin typeface="Times New Roman"/>
-              <a:cs typeface="Times New Roman"/>
-            </a:endParaRPr>
-          </a:p>
-          <a:p>
-            <a:pPr>
-              <a:lnSpc>
-                <a:spcPct val="100000"/>
-              </a:lnSpc>
-              <a:spcBef>
-                <a:spcPts val="275"/>
-              </a:spcBef>
-            </a:pPr>
-            <a:endParaRPr sz="1200">
-              <a:latin typeface="Times New Roman"/>
-              <a:cs typeface="Times New Roman"/>
-            </a:endParaRPr>
-          </a:p>
-          <a:p>
-            <a:pPr marL="360045">
-              <a:lnSpc>
-                <a:spcPct val="100000"/>
-              </a:lnSpc>
-            </a:pPr>
-            <a:r>
-              <a:rPr sz="1200" b="1" spc="90" dirty="0">
-                <a:solidFill>
-                  <a:srgbClr val="4E5862"/>
-                </a:solidFill>
-                <a:latin typeface="Tahoma"/>
-                <a:cs typeface="Tahoma"/>
-              </a:rPr>
-              <a:t>TEST</a:t>
-            </a:r>
-            <a:r>
-              <a:rPr sz="1200" b="1" spc="155" dirty="0">
-                <a:solidFill>
-                  <a:srgbClr val="4E5862"/>
-                </a:solidFill>
-                <a:latin typeface="Tahoma"/>
-                <a:cs typeface="Tahoma"/>
-              </a:rPr>
-              <a:t> </a:t>
-            </a:r>
-            <a:r>
-              <a:rPr sz="1200" b="1" spc="90" dirty="0">
-                <a:solidFill>
-                  <a:srgbClr val="4E5862"/>
-                </a:solidFill>
-                <a:latin typeface="Tahoma"/>
-                <a:cs typeface="Tahoma"/>
-              </a:rPr>
-              <a:t>ACCURACY</a:t>
-            </a:r>
-            <a:endParaRPr sz="1200">
-              <a:latin typeface="Tahoma"/>
-              <a:cs typeface="Tahoma"/>
-            </a:endParaRPr>
-          </a:p>
-          <a:p>
-            <a:pPr marL="360045">
-              <a:lnSpc>
-                <a:spcPct val="100000"/>
-              </a:lnSpc>
-              <a:spcBef>
-                <a:spcPts val="285"/>
-              </a:spcBef>
-            </a:pPr>
-            <a:r>
-              <a:rPr sz="4800" b="1" spc="-50" dirty="0">
-                <a:solidFill>
-                  <a:srgbClr val="297E7B"/>
-                </a:solidFill>
-                <a:latin typeface="Tahoma"/>
-                <a:cs typeface="Tahoma"/>
-              </a:rPr>
-              <a:t>95.86%</a:t>
-            </a:r>
-            <a:endParaRPr sz="4800">
-              <a:latin typeface="Tahoma"/>
-              <a:cs typeface="Tahoma"/>
-            </a:endParaRPr>
-          </a:p>
-        </p:txBody>
-      </p:sp>
-      <p:sp>
-        <p:nvSpPr>
-          <p:cNvPr id="7" name="object 7"/>
-          <p:cNvSpPr txBox="1"/>
-          <p:nvPr/>
-        </p:nvSpPr>
-        <p:spPr>
-          <a:xfrm>
-            <a:off x="4376737" y="4557712"/>
-            <a:ext cx="3438525" cy="1685925"/>
-          </a:xfrm>
-          <a:prstGeom prst="rect">
-            <a:avLst/>
-          </a:prstGeom>
-          <a:ln w="9524">
-            <a:solidFill>
-              <a:srgbClr val="D8D5CD"/>
-            </a:solidFill>
-          </a:ln>
-        </p:spPr>
-        <p:txBody>
-          <a:bodyPr vert="horz" wrap="square" lIns="0" tIns="0" rIns="0" bIns="0" rtlCol="0">
-            <a:spAutoFit/>
-          </a:bodyPr>
-          <a:lstStyle/>
-          <a:p>
-            <a:pPr>
-              <a:lnSpc>
-                <a:spcPct val="100000"/>
-              </a:lnSpc>
-            </a:pPr>
-            <a:endParaRPr sz="1200">
-              <a:latin typeface="Times New Roman"/>
-              <a:cs typeface="Times New Roman"/>
-            </a:endParaRPr>
-          </a:p>
-          <a:p>
-            <a:pPr>
-              <a:lnSpc>
-                <a:spcPct val="100000"/>
-              </a:lnSpc>
-              <a:spcBef>
-                <a:spcPts val="275"/>
-              </a:spcBef>
-            </a:pPr>
-            <a:endParaRPr sz="1200">
-              <a:latin typeface="Times New Roman"/>
-              <a:cs typeface="Times New Roman"/>
-            </a:endParaRPr>
-          </a:p>
-          <a:p>
-            <a:pPr marL="356870">
-              <a:lnSpc>
-                <a:spcPct val="100000"/>
-              </a:lnSpc>
-            </a:pPr>
-            <a:r>
-              <a:rPr sz="1200" b="1" spc="90" dirty="0">
-                <a:solidFill>
-                  <a:srgbClr val="4E5862"/>
-                </a:solidFill>
-                <a:latin typeface="Tahoma"/>
-                <a:cs typeface="Tahoma"/>
-              </a:rPr>
-              <a:t>CROSS-</a:t>
-            </a:r>
-            <a:r>
-              <a:rPr sz="1200" b="1" dirty="0">
-                <a:solidFill>
-                  <a:srgbClr val="4E5862"/>
-                </a:solidFill>
-                <a:latin typeface="Tahoma"/>
-                <a:cs typeface="Tahoma"/>
-              </a:rPr>
-              <a:t>VALIDATION</a:t>
-            </a:r>
-            <a:r>
-              <a:rPr sz="1200" b="1" spc="365" dirty="0">
-                <a:solidFill>
-                  <a:srgbClr val="4E5862"/>
-                </a:solidFill>
-                <a:latin typeface="Tahoma"/>
-                <a:cs typeface="Tahoma"/>
-              </a:rPr>
-              <a:t> </a:t>
-            </a:r>
-            <a:r>
-              <a:rPr sz="1200" b="1" spc="90" dirty="0">
-                <a:solidFill>
-                  <a:srgbClr val="4E5862"/>
-                </a:solidFill>
-                <a:latin typeface="Tahoma"/>
-                <a:cs typeface="Tahoma"/>
-              </a:rPr>
-              <a:t>ACCURACY</a:t>
-            </a:r>
-            <a:endParaRPr sz="1200">
-              <a:latin typeface="Tahoma"/>
-              <a:cs typeface="Tahoma"/>
-            </a:endParaRPr>
-          </a:p>
-          <a:p>
-            <a:pPr marL="356870">
-              <a:lnSpc>
-                <a:spcPct val="100000"/>
-              </a:lnSpc>
-              <a:spcBef>
-                <a:spcPts val="285"/>
-              </a:spcBef>
-            </a:pPr>
-            <a:r>
-              <a:rPr sz="4800" b="1" spc="-50" dirty="0">
-                <a:solidFill>
-                  <a:srgbClr val="297E7B"/>
-                </a:solidFill>
-                <a:latin typeface="Tahoma"/>
-                <a:cs typeface="Tahoma"/>
-              </a:rPr>
-              <a:t>96.03%</a:t>
-            </a:r>
-            <a:endParaRPr sz="4800">
-              <a:latin typeface="Tahoma"/>
-              <a:cs typeface="Tahoma"/>
-            </a:endParaRPr>
-          </a:p>
-        </p:txBody>
-      </p:sp>
-      <p:sp>
-        <p:nvSpPr>
-          <p:cNvPr id="8" name="object 8"/>
-          <p:cNvSpPr txBox="1"/>
-          <p:nvPr/>
-        </p:nvSpPr>
-        <p:spPr>
-          <a:xfrm>
-            <a:off x="8129586" y="4557712"/>
-            <a:ext cx="3448050" cy="1369606"/>
-          </a:xfrm>
-          <a:prstGeom prst="rect">
-            <a:avLst/>
-          </a:prstGeom>
-          <a:ln w="9524">
-            <a:solidFill>
-              <a:srgbClr val="D8D5CD"/>
-            </a:solidFill>
-          </a:ln>
-        </p:spPr>
-        <p:txBody>
-          <a:bodyPr vert="horz" wrap="square" lIns="0" tIns="0" rIns="0" bIns="0" rtlCol="0">
-            <a:spAutoFit/>
-          </a:bodyPr>
-          <a:lstStyle/>
-          <a:p>
-            <a:pPr>
-              <a:lnSpc>
-                <a:spcPct val="100000"/>
-              </a:lnSpc>
-            </a:pPr>
-            <a:endParaRPr sz="1200" dirty="0">
-              <a:latin typeface="Times New Roman"/>
-              <a:cs typeface="Times New Roman"/>
-            </a:endParaRPr>
-          </a:p>
-          <a:p>
-            <a:pPr>
-              <a:lnSpc>
-                <a:spcPct val="100000"/>
-              </a:lnSpc>
-              <a:spcBef>
-                <a:spcPts val="275"/>
-              </a:spcBef>
-            </a:pPr>
-            <a:endParaRPr sz="1200" dirty="0">
-              <a:latin typeface="Times New Roman"/>
-              <a:cs typeface="Times New Roman"/>
-            </a:endParaRPr>
-          </a:p>
-          <a:p>
-            <a:pPr marL="363220">
-              <a:lnSpc>
-                <a:spcPct val="100000"/>
-              </a:lnSpc>
-            </a:pPr>
-            <a:r>
-              <a:rPr sz="1200" b="1" spc="90" dirty="0">
-                <a:solidFill>
-                  <a:srgbClr val="4E5862"/>
-                </a:solidFill>
-                <a:latin typeface="Tahoma"/>
-                <a:cs typeface="Tahoma"/>
-              </a:rPr>
-              <a:t>CROSS-</a:t>
-            </a:r>
-            <a:r>
-              <a:rPr sz="1200" b="1" dirty="0">
-                <a:solidFill>
-                  <a:srgbClr val="4E5862"/>
-                </a:solidFill>
-                <a:latin typeface="Tahoma"/>
-                <a:cs typeface="Tahoma"/>
-              </a:rPr>
-              <a:t>VALIDATION</a:t>
-            </a:r>
-            <a:r>
-              <a:rPr sz="1200" b="1" spc="310" dirty="0">
-                <a:solidFill>
-                  <a:srgbClr val="4E5862"/>
-                </a:solidFill>
-                <a:latin typeface="Tahoma"/>
-                <a:cs typeface="Tahoma"/>
-              </a:rPr>
-              <a:t> </a:t>
-            </a:r>
-            <a:r>
-              <a:rPr sz="1200" b="1" dirty="0">
-                <a:solidFill>
-                  <a:srgbClr val="4E5862"/>
-                </a:solidFill>
-                <a:latin typeface="Tahoma"/>
-                <a:cs typeface="Tahoma"/>
-              </a:rPr>
-              <a:t>LOG</a:t>
-            </a:r>
-            <a:r>
-              <a:rPr sz="1200" b="1" spc="315" dirty="0">
-                <a:solidFill>
-                  <a:srgbClr val="4E5862"/>
-                </a:solidFill>
-                <a:latin typeface="Tahoma"/>
-                <a:cs typeface="Tahoma"/>
-              </a:rPr>
-              <a:t> </a:t>
-            </a:r>
-            <a:r>
-              <a:rPr sz="1200" b="1" spc="40" dirty="0">
-                <a:solidFill>
-                  <a:srgbClr val="4E5862"/>
-                </a:solidFill>
-                <a:latin typeface="Tahoma"/>
-                <a:cs typeface="Tahoma"/>
-              </a:rPr>
-              <a:t>LOSS</a:t>
-            </a:r>
-            <a:endParaRPr sz="1200" dirty="0">
-              <a:latin typeface="Tahoma"/>
-              <a:cs typeface="Tahoma"/>
-            </a:endParaRPr>
-          </a:p>
-          <a:p>
-            <a:pPr marL="363220">
-              <a:lnSpc>
-                <a:spcPct val="100000"/>
-              </a:lnSpc>
-              <a:spcBef>
-                <a:spcPts val="285"/>
-              </a:spcBef>
-            </a:pPr>
-            <a:r>
-              <a:rPr lang="en-IN" sz="4800" dirty="0"/>
-              <a:t>0.171</a:t>
-            </a:r>
-            <a:endParaRPr sz="4800" dirty="0">
-              <a:latin typeface="Tahoma"/>
-              <a:cs typeface="Tahoma"/>
-            </a:endParaRPr>
-          </a:p>
-        </p:txBody>
-      </p:sp>
-      <p:sp>
-        <p:nvSpPr>
-          <p:cNvPr id="10" name="object 10"/>
-          <p:cNvSpPr txBox="1"/>
-          <p:nvPr/>
-        </p:nvSpPr>
-        <p:spPr>
-          <a:xfrm>
-            <a:off x="11341248" y="6452851"/>
-            <a:ext cx="229235" cy="194945"/>
-          </a:xfrm>
-          <a:prstGeom prst="rect">
-            <a:avLst/>
-          </a:prstGeom>
-        </p:spPr>
-        <p:txBody>
-          <a:bodyPr vert="horz" wrap="square" lIns="0" tIns="8255" rIns="0" bIns="0" rtlCol="0">
-            <a:spAutoFit/>
-          </a:bodyPr>
-          <a:lstStyle/>
-          <a:p>
-            <a:pPr marL="12700">
-              <a:lnSpc>
-                <a:spcPct val="100000"/>
-              </a:lnSpc>
-              <a:spcBef>
-                <a:spcPts val="65"/>
-              </a:spcBef>
-            </a:pPr>
-            <a:r>
-              <a:rPr sz="1100" dirty="0">
-                <a:solidFill>
-                  <a:srgbClr val="17324A"/>
-                </a:solidFill>
-                <a:latin typeface="Verdana"/>
-                <a:cs typeface="Verdana"/>
-                <a:hlinkClick r:id="rId2"/>
-              </a:rPr>
-              <a:t>0</a:t>
-            </a:r>
-            <a:r>
-              <a:rPr sz="1100" spc="-185" dirty="0">
-                <a:solidFill>
-                  <a:srgbClr val="17324A"/>
-                </a:solidFill>
-                <a:latin typeface="Verdana"/>
-                <a:cs typeface="Verdana"/>
-                <a:hlinkClick r:id="rId2"/>
-              </a:rPr>
-              <a:t> </a:t>
-            </a:r>
-            <a:r>
-              <a:rPr sz="1100" spc="-50" dirty="0">
-                <a:solidFill>
-                  <a:srgbClr val="17324A"/>
-                </a:solidFill>
-                <a:latin typeface="Verdana"/>
-                <a:cs typeface="Verdana"/>
-                <a:hlinkClick r:id="rId2"/>
-              </a:rPr>
-              <a:t>9</a:t>
-            </a:r>
-            <a:endParaRPr sz="1100">
-              <a:latin typeface="Verdana"/>
-              <a:cs typeface="Verdana"/>
-            </a:endParaRPr>
-          </a:p>
-        </p:txBody>
-      </p:sp>
-    </p:spTree>
-  </p:cSld>
-  <p:clrMapOvr>
-    <a:masterClrMapping/>
-  </p:clrMapOvr>
-</p:sld>
-</file>
-
-<file path=ppt/slides/slide11.xml><?xml version="1.0" encoding="utf-8"?>
 <p:sld xmlns:a="http://schemas.openxmlformats.org/drawingml/2006/main" xmlns:r="http://schemas.openxmlformats.org/officeDocument/2006/relationships" xmlns:p="http://schemas.openxmlformats.org/presentationml/2006/main">
   <p:cSld>
     <p:spTree>
@@ -17029,90 +16000,1008 @@
       </p:grpSpPr>
       <p:sp>
         <p:nvSpPr>
-          <p:cNvPr id="2" name="Title 1">
-            <a:extLst>
-              <a:ext uri="{FF2B5EF4-FFF2-40B4-BE49-F238E27FC236}">
-                <a16:creationId xmlns:a16="http://schemas.microsoft.com/office/drawing/2014/main" id="{80DB4246-07B6-1FFF-FEE4-74DE3FE0D14D}"/>
-              </a:ext>
-            </a:extLst>
-          </p:cNvPr>
-          <p:cNvSpPr>
+          <p:cNvPr id="2" name="object 2"/>
+          <p:cNvSpPr txBox="1"/>
+          <p:nvPr/>
+        </p:nvSpPr>
+        <p:spPr>
+          <a:xfrm>
+            <a:off x="596899" y="596900"/>
+            <a:ext cx="772795" cy="208279"/>
+          </a:xfrm>
+          <a:prstGeom prst="rect">
+            <a:avLst/>
+          </a:prstGeom>
+        </p:spPr>
+        <p:txBody>
+          <a:bodyPr vert="horz" wrap="square" lIns="0" tIns="12700" rIns="0" bIns="0" rtlCol="0">
+            <a:spAutoFit/>
+          </a:bodyPr>
+          <a:lstStyle/>
+          <a:p>
+            <a:pPr marL="12700">
+              <a:lnSpc>
+                <a:spcPct val="100000"/>
+              </a:lnSpc>
+              <a:spcBef>
+                <a:spcPts val="100"/>
+              </a:spcBef>
+            </a:pPr>
+            <a:r>
+              <a:rPr sz="1200" b="1" spc="45" dirty="0">
+                <a:solidFill>
+                  <a:srgbClr val="3D5C73"/>
+                </a:solidFill>
+                <a:latin typeface="Tahoma"/>
+                <a:cs typeface="Tahoma"/>
+              </a:rPr>
+              <a:t>RESULTS</a:t>
+            </a:r>
+            <a:endParaRPr sz="1200">
+              <a:latin typeface="Tahoma"/>
+              <a:cs typeface="Tahoma"/>
+            </a:endParaRPr>
+          </a:p>
+        </p:txBody>
+      </p:sp>
+      <p:sp>
+        <p:nvSpPr>
+          <p:cNvPr id="3" name="object 3" descr="$PPTXTitle"/>
+          <p:cNvSpPr txBox="1">
             <a:spLocks noGrp="1"/>
           </p:cNvSpPr>
           <p:nvPr>
             <p:ph type="title"/>
           </p:nvPr>
         </p:nvSpPr>
-        <p:spPr/>
+        <p:spPr>
+          <a:xfrm>
+            <a:off x="596899" y="863600"/>
+            <a:ext cx="9313545" cy="482600"/>
+          </a:xfrm>
+          <a:prstGeom prst="rect">
+            <a:avLst/>
+          </a:prstGeom>
+        </p:spPr>
         <p:txBody>
-          <a:bodyPr/>
+          <a:bodyPr vert="horz" wrap="square" lIns="0" tIns="12700" rIns="0" bIns="0" rtlCol="0">
+            <a:spAutoFit/>
+          </a:bodyPr>
           <a:lstStyle/>
           <a:p>
-            <a:endParaRPr lang="en-IN"/>
+            <a:pPr marL="12700">
+              <a:lnSpc>
+                <a:spcPct val="100000"/>
+              </a:lnSpc>
+              <a:spcBef>
+                <a:spcPts val="100"/>
+              </a:spcBef>
+            </a:pPr>
+            <a:r>
+              <a:rPr spc="-130" dirty="0"/>
+              <a:t>Random</a:t>
+            </a:r>
+            <a:r>
+              <a:rPr spc="-114" dirty="0"/>
+              <a:t> </a:t>
+            </a:r>
+            <a:r>
+              <a:rPr spc="-90" dirty="0"/>
+              <a:t>Forest</a:t>
+            </a:r>
+            <a:r>
+              <a:rPr spc="-114" dirty="0"/>
+              <a:t> </a:t>
+            </a:r>
+            <a:r>
+              <a:rPr spc="-75" dirty="0"/>
+              <a:t>was</a:t>
+            </a:r>
+            <a:r>
+              <a:rPr spc="-114" dirty="0"/>
+              <a:t> </a:t>
+            </a:r>
+            <a:r>
+              <a:rPr spc="-120" dirty="0"/>
+              <a:t>the</a:t>
+            </a:r>
+            <a:r>
+              <a:rPr spc="-114" dirty="0"/>
+              <a:t> </a:t>
+            </a:r>
+            <a:r>
+              <a:rPr spc="-85" dirty="0"/>
+              <a:t>strongest</a:t>
+            </a:r>
+            <a:r>
+              <a:rPr spc="-114" dirty="0"/>
+              <a:t> </a:t>
+            </a:r>
+            <a:r>
+              <a:rPr spc="-110" dirty="0"/>
+              <a:t>overall</a:t>
+            </a:r>
+            <a:r>
+              <a:rPr spc="-114" dirty="0"/>
+              <a:t> </a:t>
+            </a:r>
+            <a:r>
+              <a:rPr spc="-40" dirty="0"/>
+              <a:t>extension</a:t>
+            </a:r>
           </a:p>
         </p:txBody>
       </p:sp>
       <p:sp>
         <p:nvSpPr>
-          <p:cNvPr id="3" name="Text Placeholder 2">
-            <a:extLst>
-              <a:ext uri="{FF2B5EF4-FFF2-40B4-BE49-F238E27FC236}">
-                <a16:creationId xmlns:a16="http://schemas.microsoft.com/office/drawing/2014/main" id="{C2A851A0-53BB-BF88-357B-EDFB3288C0AB}"/>
-              </a:ext>
-            </a:extLst>
-          </p:cNvPr>
-          <p:cNvSpPr>
-            <a:spLocks noGrp="1"/>
-          </p:cNvSpPr>
-          <p:nvPr>
-            <p:ph type="body" idx="1"/>
-          </p:nvPr>
+          <p:cNvPr id="4" name="object 4"/>
+          <p:cNvSpPr/>
+          <p:nvPr/>
         </p:nvSpPr>
-        <p:spPr/>
+        <p:spPr>
+          <a:xfrm>
+            <a:off x="609599" y="1714499"/>
+            <a:ext cx="10972800" cy="9525"/>
+          </a:xfrm>
+          <a:custGeom>
+            <a:avLst/>
+            <a:gdLst/>
+            <a:ahLst/>
+            <a:cxnLst/>
+            <a:rect l="l" t="t" r="r" b="b"/>
+            <a:pathLst>
+              <a:path w="10972800" h="9525">
+                <a:moveTo>
+                  <a:pt x="10969351" y="9524"/>
+                </a:moveTo>
+                <a:lnTo>
+                  <a:pt x="3447" y="9524"/>
+                </a:lnTo>
+                <a:lnTo>
+                  <a:pt x="2324" y="9059"/>
+                </a:lnTo>
+                <a:lnTo>
+                  <a:pt x="464" y="7200"/>
+                </a:lnTo>
+                <a:lnTo>
+                  <a:pt x="0" y="6077"/>
+                </a:lnTo>
+                <a:lnTo>
+                  <a:pt x="0" y="4762"/>
+                </a:lnTo>
+                <a:lnTo>
+                  <a:pt x="0" y="3447"/>
+                </a:lnTo>
+                <a:lnTo>
+                  <a:pt x="464" y="2324"/>
+                </a:lnTo>
+                <a:lnTo>
+                  <a:pt x="2324" y="464"/>
+                </a:lnTo>
+                <a:lnTo>
+                  <a:pt x="3447" y="0"/>
+                </a:lnTo>
+                <a:lnTo>
+                  <a:pt x="10969351" y="0"/>
+                </a:lnTo>
+                <a:lnTo>
+                  <a:pt x="10970473" y="464"/>
+                </a:lnTo>
+                <a:lnTo>
+                  <a:pt x="10972332" y="2324"/>
+                </a:lnTo>
+                <a:lnTo>
+                  <a:pt x="10972798" y="3447"/>
+                </a:lnTo>
+                <a:lnTo>
+                  <a:pt x="10972798" y="6077"/>
+                </a:lnTo>
+                <a:lnTo>
+                  <a:pt x="10972332" y="7200"/>
+                </a:lnTo>
+                <a:lnTo>
+                  <a:pt x="10970473" y="9059"/>
+                </a:lnTo>
+                <a:lnTo>
+                  <a:pt x="10969351" y="9524"/>
+                </a:lnTo>
+                <a:close/>
+              </a:path>
+            </a:pathLst>
+          </a:custGeom>
+          <a:solidFill>
+            <a:srgbClr val="17324A"/>
+          </a:solidFill>
+        </p:spPr>
         <p:txBody>
-          <a:bodyPr/>
+          <a:bodyPr wrap="square" lIns="0" tIns="0" rIns="0" bIns="0" rtlCol="0"/>
           <a:lstStyle/>
           <a:p>
-            <a:endParaRPr lang="en-IN" dirty="0"/>
+            <a:endParaRPr/>
           </a:p>
         </p:txBody>
       </p:sp>
-      <p:pic>
-        <p:nvPicPr>
-          <p:cNvPr id="5" name="Picture 4">
-            <a:extLst>
-              <a:ext uri="{FF2B5EF4-FFF2-40B4-BE49-F238E27FC236}">
-                <a16:creationId xmlns:a16="http://schemas.microsoft.com/office/drawing/2014/main" id="{05306267-042E-D70A-0915-7DE9AF8F30B7}"/>
-              </a:ext>
-            </a:extLst>
-          </p:cNvPr>
-          <p:cNvPicPr>
-            <a:picLocks noChangeAspect="1"/>
-          </p:cNvPicPr>
+      <p:sp>
+        <p:nvSpPr>
+          <p:cNvPr id="5" name="object 5"/>
+          <p:cNvSpPr txBox="1"/>
           <p:nvPr/>
-        </p:nvPicPr>
-        <p:blipFill>
-          <a:blip r:embed="rId2"/>
-          <a:stretch>
-            <a:fillRect/>
-          </a:stretch>
-        </p:blipFill>
+        </p:nvSpPr>
         <p:spPr>
           <a:xfrm>
-            <a:off x="58057" y="0"/>
-            <a:ext cx="12075886" cy="6858000"/>
+            <a:off x="596899" y="2009762"/>
+            <a:ext cx="6839584" cy="1206500"/>
           </a:xfrm>
           <a:prstGeom prst="rect">
             <a:avLst/>
           </a:prstGeom>
         </p:spPr>
-      </p:pic>
+        <p:txBody>
+          <a:bodyPr vert="horz" wrap="square" lIns="0" tIns="7620" rIns="0" bIns="0" rtlCol="0">
+            <a:spAutoFit/>
+          </a:bodyPr>
+          <a:lstStyle/>
+          <a:p>
+            <a:pPr marL="12700" marR="5080" algn="just">
+              <a:lnSpc>
+                <a:spcPct val="129700"/>
+              </a:lnSpc>
+              <a:spcBef>
+                <a:spcPts val="60"/>
+              </a:spcBef>
+            </a:pPr>
+            <a:r>
+              <a:rPr sz="2000" spc="70" dirty="0">
+                <a:solidFill>
+                  <a:srgbClr val="4E5862"/>
+                </a:solidFill>
+                <a:latin typeface="Tahoma"/>
+                <a:cs typeface="Tahoma"/>
+              </a:rPr>
+              <a:t>Multiple</a:t>
+            </a:r>
+            <a:r>
+              <a:rPr sz="2000" spc="-50" dirty="0">
+                <a:solidFill>
+                  <a:srgbClr val="4E5862"/>
+                </a:solidFill>
+                <a:latin typeface="Tahoma"/>
+                <a:cs typeface="Tahoma"/>
+              </a:rPr>
+              <a:t> </a:t>
+            </a:r>
+            <a:r>
+              <a:rPr sz="2000" spc="95" dirty="0">
+                <a:solidFill>
+                  <a:srgbClr val="4E5862"/>
+                </a:solidFill>
+                <a:latin typeface="Tahoma"/>
+                <a:cs typeface="Tahoma"/>
+              </a:rPr>
+              <a:t>decision</a:t>
+            </a:r>
+            <a:r>
+              <a:rPr sz="2000" spc="-45" dirty="0">
+                <a:solidFill>
+                  <a:srgbClr val="4E5862"/>
+                </a:solidFill>
+                <a:latin typeface="Tahoma"/>
+                <a:cs typeface="Tahoma"/>
+              </a:rPr>
+              <a:t> </a:t>
+            </a:r>
+            <a:r>
+              <a:rPr sz="2000" spc="65" dirty="0">
+                <a:solidFill>
+                  <a:srgbClr val="4E5862"/>
+                </a:solidFill>
+                <a:latin typeface="Tahoma"/>
+                <a:cs typeface="Tahoma"/>
+              </a:rPr>
+              <a:t>trees</a:t>
+            </a:r>
+            <a:r>
+              <a:rPr sz="2000" spc="-45" dirty="0">
+                <a:solidFill>
+                  <a:srgbClr val="4E5862"/>
+                </a:solidFill>
+                <a:latin typeface="Tahoma"/>
+                <a:cs typeface="Tahoma"/>
+              </a:rPr>
+              <a:t> </a:t>
+            </a:r>
+            <a:r>
+              <a:rPr sz="2000" spc="114" dirty="0">
+                <a:solidFill>
+                  <a:srgbClr val="4E5862"/>
+                </a:solidFill>
+                <a:latin typeface="Tahoma"/>
+                <a:cs typeface="Tahoma"/>
+              </a:rPr>
+              <a:t>can</a:t>
+            </a:r>
+            <a:r>
+              <a:rPr sz="2000" spc="-45" dirty="0">
+                <a:solidFill>
+                  <a:srgbClr val="4E5862"/>
+                </a:solidFill>
+                <a:latin typeface="Tahoma"/>
+                <a:cs typeface="Tahoma"/>
+              </a:rPr>
+              <a:t> </a:t>
+            </a:r>
+            <a:r>
+              <a:rPr sz="2000" spc="80" dirty="0">
+                <a:solidFill>
+                  <a:srgbClr val="4E5862"/>
+                </a:solidFill>
+                <a:latin typeface="Tahoma"/>
+                <a:cs typeface="Tahoma"/>
+              </a:rPr>
+              <a:t>model</a:t>
+            </a:r>
+            <a:r>
+              <a:rPr sz="2000" spc="-45" dirty="0">
+                <a:solidFill>
+                  <a:srgbClr val="4E5862"/>
+                </a:solidFill>
+                <a:latin typeface="Tahoma"/>
+                <a:cs typeface="Tahoma"/>
+              </a:rPr>
+              <a:t> </a:t>
+            </a:r>
+            <a:r>
+              <a:rPr sz="2000" spc="55" dirty="0">
+                <a:solidFill>
+                  <a:srgbClr val="4E5862"/>
+                </a:solidFill>
+                <a:latin typeface="Tahoma"/>
+                <a:cs typeface="Tahoma"/>
+              </a:rPr>
+              <a:t>nonlinear</a:t>
+            </a:r>
+            <a:r>
+              <a:rPr sz="2000" spc="-50" dirty="0">
+                <a:solidFill>
+                  <a:srgbClr val="4E5862"/>
+                </a:solidFill>
+                <a:latin typeface="Tahoma"/>
+                <a:cs typeface="Tahoma"/>
+              </a:rPr>
+              <a:t> </a:t>
+            </a:r>
+            <a:r>
+              <a:rPr sz="2000" spc="50" dirty="0">
+                <a:solidFill>
+                  <a:srgbClr val="4E5862"/>
+                </a:solidFill>
+                <a:latin typeface="Tahoma"/>
+                <a:cs typeface="Tahoma"/>
+              </a:rPr>
+              <a:t>relationships </a:t>
+            </a:r>
+            <a:r>
+              <a:rPr sz="2000" spc="65" dirty="0">
+                <a:solidFill>
+                  <a:srgbClr val="4E5862"/>
+                </a:solidFill>
+                <a:latin typeface="Tahoma"/>
+                <a:cs typeface="Tahoma"/>
+              </a:rPr>
+              <a:t>while</a:t>
+            </a:r>
+            <a:r>
+              <a:rPr sz="2000" spc="-35" dirty="0">
+                <a:solidFill>
+                  <a:srgbClr val="4E5862"/>
+                </a:solidFill>
+                <a:latin typeface="Tahoma"/>
+                <a:cs typeface="Tahoma"/>
+              </a:rPr>
+              <a:t> </a:t>
+            </a:r>
+            <a:r>
+              <a:rPr sz="2000" spc="50" dirty="0">
+                <a:solidFill>
+                  <a:srgbClr val="4E5862"/>
+                </a:solidFill>
+                <a:latin typeface="Tahoma"/>
+                <a:cs typeface="Tahoma"/>
+              </a:rPr>
+              <a:t>remaining</a:t>
+            </a:r>
+            <a:r>
+              <a:rPr sz="2000" spc="-30" dirty="0">
+                <a:solidFill>
+                  <a:srgbClr val="4E5862"/>
+                </a:solidFill>
+                <a:latin typeface="Tahoma"/>
+                <a:cs typeface="Tahoma"/>
+              </a:rPr>
+              <a:t> </a:t>
+            </a:r>
+            <a:r>
+              <a:rPr sz="2000" spc="65" dirty="0">
+                <a:solidFill>
+                  <a:srgbClr val="4E5862"/>
+                </a:solidFill>
+                <a:latin typeface="Tahoma"/>
+                <a:cs typeface="Tahoma"/>
+              </a:rPr>
+              <a:t>robust</a:t>
+            </a:r>
+            <a:r>
+              <a:rPr sz="2000" spc="-30" dirty="0">
+                <a:solidFill>
+                  <a:srgbClr val="4E5862"/>
+                </a:solidFill>
+                <a:latin typeface="Tahoma"/>
+                <a:cs typeface="Tahoma"/>
+              </a:rPr>
+              <a:t> </a:t>
+            </a:r>
+            <a:r>
+              <a:rPr sz="2000" spc="110" dirty="0">
+                <a:solidFill>
+                  <a:srgbClr val="4E5862"/>
+                </a:solidFill>
+                <a:latin typeface="Tahoma"/>
+                <a:cs typeface="Tahoma"/>
+              </a:rPr>
+              <a:t>across</a:t>
+            </a:r>
+            <a:r>
+              <a:rPr sz="2000" spc="-30" dirty="0">
+                <a:solidFill>
+                  <a:srgbClr val="4E5862"/>
+                </a:solidFill>
+                <a:latin typeface="Tahoma"/>
+                <a:cs typeface="Tahoma"/>
+              </a:rPr>
+              <a:t> </a:t>
+            </a:r>
+            <a:r>
+              <a:rPr sz="2000" dirty="0">
+                <a:solidFill>
+                  <a:srgbClr val="4E5862"/>
+                </a:solidFill>
+                <a:latin typeface="Tahoma"/>
+                <a:cs typeface="Tahoma"/>
+              </a:rPr>
+              <a:t>the</a:t>
+            </a:r>
+            <a:r>
+              <a:rPr sz="2000" spc="-30" dirty="0">
+                <a:solidFill>
+                  <a:srgbClr val="4E5862"/>
+                </a:solidFill>
+                <a:latin typeface="Tahoma"/>
+                <a:cs typeface="Tahoma"/>
+              </a:rPr>
+              <a:t> </a:t>
+            </a:r>
+            <a:r>
+              <a:rPr sz="2000" spc="95" dirty="0">
+                <a:solidFill>
+                  <a:srgbClr val="4E5862"/>
+                </a:solidFill>
+                <a:latin typeface="Tahoma"/>
+                <a:cs typeface="Tahoma"/>
+              </a:rPr>
+              <a:t>same</a:t>
+            </a:r>
+            <a:r>
+              <a:rPr sz="2000" spc="-35" dirty="0">
+                <a:solidFill>
+                  <a:srgbClr val="4E5862"/>
+                </a:solidFill>
+                <a:latin typeface="Tahoma"/>
+                <a:cs typeface="Tahoma"/>
+              </a:rPr>
+              <a:t> </a:t>
+            </a:r>
+            <a:r>
+              <a:rPr sz="2000" spc="65" dirty="0">
+                <a:solidFill>
+                  <a:srgbClr val="4E5862"/>
+                </a:solidFill>
+                <a:latin typeface="Tahoma"/>
+                <a:cs typeface="Tahoma"/>
+              </a:rPr>
+              <a:t>financial</a:t>
+            </a:r>
+            <a:r>
+              <a:rPr sz="2000" spc="-30" dirty="0">
+                <a:solidFill>
+                  <a:srgbClr val="4E5862"/>
+                </a:solidFill>
+                <a:latin typeface="Tahoma"/>
+                <a:cs typeface="Tahoma"/>
+              </a:rPr>
+              <a:t> </a:t>
+            </a:r>
+            <a:r>
+              <a:rPr sz="2000" spc="40" dirty="0">
+                <a:solidFill>
+                  <a:srgbClr val="4E5862"/>
+                </a:solidFill>
+                <a:latin typeface="Tahoma"/>
+                <a:cs typeface="Tahoma"/>
+              </a:rPr>
+              <a:t>feature </a:t>
+            </a:r>
+            <a:r>
+              <a:rPr sz="2000" spc="95" dirty="0">
+                <a:solidFill>
+                  <a:srgbClr val="4E5862"/>
+                </a:solidFill>
+                <a:latin typeface="Tahoma"/>
+                <a:cs typeface="Tahoma"/>
+              </a:rPr>
+              <a:t>space.</a:t>
+            </a:r>
+            <a:endParaRPr sz="2000">
+              <a:latin typeface="Tahoma"/>
+              <a:cs typeface="Tahoma"/>
+            </a:endParaRPr>
+          </a:p>
+        </p:txBody>
+      </p:sp>
+      <p:sp>
+        <p:nvSpPr>
+          <p:cNvPr id="6" name="object 6"/>
+          <p:cNvSpPr txBox="1"/>
+          <p:nvPr/>
+        </p:nvSpPr>
+        <p:spPr>
+          <a:xfrm>
+            <a:off x="614362" y="4557712"/>
+            <a:ext cx="3448050" cy="1685925"/>
+          </a:xfrm>
+          <a:prstGeom prst="rect">
+            <a:avLst/>
+          </a:prstGeom>
+          <a:ln w="9524">
+            <a:solidFill>
+              <a:srgbClr val="D8D5CD"/>
+            </a:solidFill>
+          </a:ln>
+        </p:spPr>
+        <p:txBody>
+          <a:bodyPr vert="horz" wrap="square" lIns="0" tIns="0" rIns="0" bIns="0" rtlCol="0">
+            <a:spAutoFit/>
+          </a:bodyPr>
+          <a:lstStyle/>
+          <a:p>
+            <a:pPr>
+              <a:lnSpc>
+                <a:spcPct val="100000"/>
+              </a:lnSpc>
+            </a:pPr>
+            <a:endParaRPr sz="1200">
+              <a:latin typeface="Times New Roman"/>
+              <a:cs typeface="Times New Roman"/>
+            </a:endParaRPr>
+          </a:p>
+          <a:p>
+            <a:pPr>
+              <a:lnSpc>
+                <a:spcPct val="100000"/>
+              </a:lnSpc>
+              <a:spcBef>
+                <a:spcPts val="275"/>
+              </a:spcBef>
+            </a:pPr>
+            <a:endParaRPr sz="1200">
+              <a:latin typeface="Times New Roman"/>
+              <a:cs typeface="Times New Roman"/>
+            </a:endParaRPr>
+          </a:p>
+          <a:p>
+            <a:pPr marL="360045">
+              <a:lnSpc>
+                <a:spcPct val="100000"/>
+              </a:lnSpc>
+            </a:pPr>
+            <a:r>
+              <a:rPr sz="1200" b="1" spc="90" dirty="0">
+                <a:solidFill>
+                  <a:srgbClr val="4E5862"/>
+                </a:solidFill>
+                <a:latin typeface="Tahoma"/>
+                <a:cs typeface="Tahoma"/>
+              </a:rPr>
+              <a:t>TEST</a:t>
+            </a:r>
+            <a:r>
+              <a:rPr sz="1200" b="1" spc="155" dirty="0">
+                <a:solidFill>
+                  <a:srgbClr val="4E5862"/>
+                </a:solidFill>
+                <a:latin typeface="Tahoma"/>
+                <a:cs typeface="Tahoma"/>
+              </a:rPr>
+              <a:t> </a:t>
+            </a:r>
+            <a:r>
+              <a:rPr sz="1200" b="1" spc="90" dirty="0">
+                <a:solidFill>
+                  <a:srgbClr val="4E5862"/>
+                </a:solidFill>
+                <a:latin typeface="Tahoma"/>
+                <a:cs typeface="Tahoma"/>
+              </a:rPr>
+              <a:t>ACCURACY</a:t>
+            </a:r>
+            <a:endParaRPr sz="1200">
+              <a:latin typeface="Tahoma"/>
+              <a:cs typeface="Tahoma"/>
+            </a:endParaRPr>
+          </a:p>
+          <a:p>
+            <a:pPr marL="360045">
+              <a:lnSpc>
+                <a:spcPct val="100000"/>
+              </a:lnSpc>
+              <a:spcBef>
+                <a:spcPts val="285"/>
+              </a:spcBef>
+            </a:pPr>
+            <a:r>
+              <a:rPr sz="4800" b="1" spc="-50" dirty="0">
+                <a:solidFill>
+                  <a:srgbClr val="297E7B"/>
+                </a:solidFill>
+                <a:latin typeface="Tahoma"/>
+                <a:cs typeface="Tahoma"/>
+              </a:rPr>
+              <a:t>95.86%</a:t>
+            </a:r>
+            <a:endParaRPr sz="4800">
+              <a:latin typeface="Tahoma"/>
+              <a:cs typeface="Tahoma"/>
+            </a:endParaRPr>
+          </a:p>
+        </p:txBody>
+      </p:sp>
+      <p:sp>
+        <p:nvSpPr>
+          <p:cNvPr id="7" name="object 7"/>
+          <p:cNvSpPr txBox="1"/>
+          <p:nvPr/>
+        </p:nvSpPr>
+        <p:spPr>
+          <a:xfrm>
+            <a:off x="4376737" y="4557712"/>
+            <a:ext cx="3438525" cy="1685925"/>
+          </a:xfrm>
+          <a:prstGeom prst="rect">
+            <a:avLst/>
+          </a:prstGeom>
+          <a:ln w="9524">
+            <a:solidFill>
+              <a:srgbClr val="D8D5CD"/>
+            </a:solidFill>
+          </a:ln>
+        </p:spPr>
+        <p:txBody>
+          <a:bodyPr vert="horz" wrap="square" lIns="0" tIns="0" rIns="0" bIns="0" rtlCol="0">
+            <a:spAutoFit/>
+          </a:bodyPr>
+          <a:lstStyle/>
+          <a:p>
+            <a:pPr>
+              <a:lnSpc>
+                <a:spcPct val="100000"/>
+              </a:lnSpc>
+            </a:pPr>
+            <a:endParaRPr sz="1200">
+              <a:latin typeface="Times New Roman"/>
+              <a:cs typeface="Times New Roman"/>
+            </a:endParaRPr>
+          </a:p>
+          <a:p>
+            <a:pPr>
+              <a:lnSpc>
+                <a:spcPct val="100000"/>
+              </a:lnSpc>
+              <a:spcBef>
+                <a:spcPts val="275"/>
+              </a:spcBef>
+            </a:pPr>
+            <a:endParaRPr sz="1200">
+              <a:latin typeface="Times New Roman"/>
+              <a:cs typeface="Times New Roman"/>
+            </a:endParaRPr>
+          </a:p>
+          <a:p>
+            <a:pPr marL="356870">
+              <a:lnSpc>
+                <a:spcPct val="100000"/>
+              </a:lnSpc>
+            </a:pPr>
+            <a:r>
+              <a:rPr sz="1200" b="1" spc="90" dirty="0">
+                <a:solidFill>
+                  <a:srgbClr val="4E5862"/>
+                </a:solidFill>
+                <a:latin typeface="Tahoma"/>
+                <a:cs typeface="Tahoma"/>
+              </a:rPr>
+              <a:t>CROSS-</a:t>
+            </a:r>
+            <a:r>
+              <a:rPr sz="1200" b="1" dirty="0">
+                <a:solidFill>
+                  <a:srgbClr val="4E5862"/>
+                </a:solidFill>
+                <a:latin typeface="Tahoma"/>
+                <a:cs typeface="Tahoma"/>
+              </a:rPr>
+              <a:t>VALIDATION</a:t>
+            </a:r>
+            <a:r>
+              <a:rPr sz="1200" b="1" spc="365" dirty="0">
+                <a:solidFill>
+                  <a:srgbClr val="4E5862"/>
+                </a:solidFill>
+                <a:latin typeface="Tahoma"/>
+                <a:cs typeface="Tahoma"/>
+              </a:rPr>
+              <a:t> </a:t>
+            </a:r>
+            <a:r>
+              <a:rPr sz="1200" b="1" spc="90" dirty="0">
+                <a:solidFill>
+                  <a:srgbClr val="4E5862"/>
+                </a:solidFill>
+                <a:latin typeface="Tahoma"/>
+                <a:cs typeface="Tahoma"/>
+              </a:rPr>
+              <a:t>ACCURACY</a:t>
+            </a:r>
+            <a:endParaRPr sz="1200">
+              <a:latin typeface="Tahoma"/>
+              <a:cs typeface="Tahoma"/>
+            </a:endParaRPr>
+          </a:p>
+          <a:p>
+            <a:pPr marL="356870">
+              <a:lnSpc>
+                <a:spcPct val="100000"/>
+              </a:lnSpc>
+              <a:spcBef>
+                <a:spcPts val="285"/>
+              </a:spcBef>
+            </a:pPr>
+            <a:r>
+              <a:rPr sz="4800" b="1" spc="-50" dirty="0">
+                <a:solidFill>
+                  <a:srgbClr val="297E7B"/>
+                </a:solidFill>
+                <a:latin typeface="Tahoma"/>
+                <a:cs typeface="Tahoma"/>
+              </a:rPr>
+              <a:t>96.03%</a:t>
+            </a:r>
+            <a:endParaRPr sz="4800">
+              <a:latin typeface="Tahoma"/>
+              <a:cs typeface="Tahoma"/>
+            </a:endParaRPr>
+          </a:p>
+        </p:txBody>
+      </p:sp>
+      <p:sp>
+        <p:nvSpPr>
+          <p:cNvPr id="8" name="object 8"/>
+          <p:cNvSpPr txBox="1"/>
+          <p:nvPr/>
+        </p:nvSpPr>
+        <p:spPr>
+          <a:xfrm>
+            <a:off x="8129586" y="4557712"/>
+            <a:ext cx="3448050" cy="1369606"/>
+          </a:xfrm>
+          <a:prstGeom prst="rect">
+            <a:avLst/>
+          </a:prstGeom>
+          <a:ln w="9524">
+            <a:solidFill>
+              <a:srgbClr val="D8D5CD"/>
+            </a:solidFill>
+          </a:ln>
+        </p:spPr>
+        <p:txBody>
+          <a:bodyPr vert="horz" wrap="square" lIns="0" tIns="0" rIns="0" bIns="0" rtlCol="0">
+            <a:spAutoFit/>
+          </a:bodyPr>
+          <a:lstStyle/>
+          <a:p>
+            <a:pPr>
+              <a:lnSpc>
+                <a:spcPct val="100000"/>
+              </a:lnSpc>
+            </a:pPr>
+            <a:endParaRPr sz="1200" dirty="0">
+              <a:latin typeface="Times New Roman"/>
+              <a:cs typeface="Times New Roman"/>
+            </a:endParaRPr>
+          </a:p>
+          <a:p>
+            <a:pPr>
+              <a:lnSpc>
+                <a:spcPct val="100000"/>
+              </a:lnSpc>
+              <a:spcBef>
+                <a:spcPts val="275"/>
+              </a:spcBef>
+            </a:pPr>
+            <a:endParaRPr sz="1200" dirty="0">
+              <a:latin typeface="Times New Roman"/>
+              <a:cs typeface="Times New Roman"/>
+            </a:endParaRPr>
+          </a:p>
+          <a:p>
+            <a:pPr marL="363220">
+              <a:lnSpc>
+                <a:spcPct val="100000"/>
+              </a:lnSpc>
+            </a:pPr>
+            <a:r>
+              <a:rPr sz="1200" b="1" spc="90" dirty="0">
+                <a:solidFill>
+                  <a:srgbClr val="4E5862"/>
+                </a:solidFill>
+                <a:latin typeface="Tahoma"/>
+                <a:cs typeface="Tahoma"/>
+              </a:rPr>
+              <a:t>CROSS-</a:t>
+            </a:r>
+            <a:r>
+              <a:rPr sz="1200" b="1" dirty="0">
+                <a:solidFill>
+                  <a:srgbClr val="4E5862"/>
+                </a:solidFill>
+                <a:latin typeface="Tahoma"/>
+                <a:cs typeface="Tahoma"/>
+              </a:rPr>
+              <a:t>VALIDATION</a:t>
+            </a:r>
+            <a:r>
+              <a:rPr sz="1200" b="1" spc="310" dirty="0">
+                <a:solidFill>
+                  <a:srgbClr val="4E5862"/>
+                </a:solidFill>
+                <a:latin typeface="Tahoma"/>
+                <a:cs typeface="Tahoma"/>
+              </a:rPr>
+              <a:t> </a:t>
+            </a:r>
+            <a:r>
+              <a:rPr sz="1200" b="1" dirty="0">
+                <a:solidFill>
+                  <a:srgbClr val="4E5862"/>
+                </a:solidFill>
+                <a:latin typeface="Tahoma"/>
+                <a:cs typeface="Tahoma"/>
+              </a:rPr>
+              <a:t>LOG</a:t>
+            </a:r>
+            <a:r>
+              <a:rPr sz="1200" b="1" spc="315" dirty="0">
+                <a:solidFill>
+                  <a:srgbClr val="4E5862"/>
+                </a:solidFill>
+                <a:latin typeface="Tahoma"/>
+                <a:cs typeface="Tahoma"/>
+              </a:rPr>
+              <a:t> </a:t>
+            </a:r>
+            <a:r>
+              <a:rPr sz="1200" b="1" spc="40" dirty="0">
+                <a:solidFill>
+                  <a:srgbClr val="4E5862"/>
+                </a:solidFill>
+                <a:latin typeface="Tahoma"/>
+                <a:cs typeface="Tahoma"/>
+              </a:rPr>
+              <a:t>LOSS</a:t>
+            </a:r>
+            <a:endParaRPr sz="1200" dirty="0">
+              <a:latin typeface="Tahoma"/>
+              <a:cs typeface="Tahoma"/>
+            </a:endParaRPr>
+          </a:p>
+          <a:p>
+            <a:pPr marL="363220">
+              <a:lnSpc>
+                <a:spcPct val="100000"/>
+              </a:lnSpc>
+              <a:spcBef>
+                <a:spcPts val="285"/>
+              </a:spcBef>
+            </a:pPr>
+            <a:r>
+              <a:rPr lang="en-IN" sz="4800" dirty="0"/>
+              <a:t>0.171</a:t>
+            </a:r>
+            <a:endParaRPr sz="4800" dirty="0">
+              <a:latin typeface="Tahoma"/>
+              <a:cs typeface="Tahoma"/>
+            </a:endParaRPr>
+          </a:p>
+        </p:txBody>
+      </p:sp>
+      <p:sp>
+        <p:nvSpPr>
+          <p:cNvPr id="10" name="object 10"/>
+          <p:cNvSpPr txBox="1"/>
+          <p:nvPr/>
+        </p:nvSpPr>
+        <p:spPr>
+          <a:xfrm>
+            <a:off x="11341248" y="6452851"/>
+            <a:ext cx="229235" cy="194945"/>
+          </a:xfrm>
+          <a:prstGeom prst="rect">
+            <a:avLst/>
+          </a:prstGeom>
+        </p:spPr>
+        <p:txBody>
+          <a:bodyPr vert="horz" wrap="square" lIns="0" tIns="8255" rIns="0" bIns="0" rtlCol="0">
+            <a:spAutoFit/>
+          </a:bodyPr>
+          <a:lstStyle/>
+          <a:p>
+            <a:pPr marL="12700">
+              <a:lnSpc>
+                <a:spcPct val="100000"/>
+              </a:lnSpc>
+              <a:spcBef>
+                <a:spcPts val="65"/>
+              </a:spcBef>
+            </a:pPr>
+            <a:r>
+              <a:rPr sz="1100" dirty="0">
+                <a:solidFill>
+                  <a:srgbClr val="17324A"/>
+                </a:solidFill>
+                <a:latin typeface="Verdana"/>
+                <a:cs typeface="Verdana"/>
+                <a:hlinkClick r:id="rId2"/>
+              </a:rPr>
+              <a:t>0</a:t>
+            </a:r>
+            <a:r>
+              <a:rPr sz="1100" spc="-185" dirty="0">
+                <a:solidFill>
+                  <a:srgbClr val="17324A"/>
+                </a:solidFill>
+                <a:latin typeface="Verdana"/>
+                <a:cs typeface="Verdana"/>
+                <a:hlinkClick r:id="rId2"/>
+              </a:rPr>
+              <a:t> </a:t>
+            </a:r>
+            <a:r>
+              <a:rPr sz="1100" spc="-50" dirty="0">
+                <a:solidFill>
+                  <a:srgbClr val="17324A"/>
+                </a:solidFill>
+                <a:latin typeface="Verdana"/>
+                <a:cs typeface="Verdana"/>
+                <a:hlinkClick r:id="rId2"/>
+              </a:rPr>
+              <a:t>9</a:t>
+            </a:r>
+            <a:endParaRPr sz="1100">
+              <a:latin typeface="Verdana"/>
+              <a:cs typeface="Verdana"/>
+            </a:endParaRPr>
+          </a:p>
+        </p:txBody>
+      </p:sp>
     </p:spTree>
-    <p:extLst>
-      <p:ext uri="{BB962C8B-B14F-4D97-AF65-F5344CB8AC3E}">
-        <p14:creationId xmlns:p14="http://schemas.microsoft.com/office/powerpoint/2010/main" val="1138689975"/>
-      </p:ext>
-    </p:extLst>
   </p:cSld>
   <p:clrMapOvr>
     <a:masterClrMapping/>

</xml_diff>